<commit_message>
Add deployment appendix slides and POC production-readiness features
Decks: 3 appendix slides per deck (POC Docker deployment, AWS and Azure
production deployment with agents, MCP server and PostgreSQL), main story
stays at 10 slides.

Production-readiness placeholders, each with a config-level upgrade path:
- Auth: demo identities or OIDC SSO (st.login); roles bound to identity,
  role-gated actions, no self-selected approval authority
- Observability: nested trace spans (pipeline -> agent -> LLM call) to
  traces.jsonl with waterfall view; optional OTLP export
- Eval harness: 50 golden checks across loans, RAG and demand (outcomes,
  field accuracy, grounding, controls); 50/50 on mock and gemma4
- Ingestion: upload application documents (txt/md/pdf), classification,
  landing folder; policy addendum upload with RAG re-index
</commit_message>
<xml_diff>
--- a/deliverables/A1_Loan_Lifecycle_Deck.pptx
+++ b/deliverables/A1_Loan_Lifecycle_Deck.pptx
@@ -15,6 +15,9 @@
     <p:sldId id="263" r:id="rId15"/>
     <p:sldId id="264" r:id="rId16"/>
     <p:sldId id="265" r:id="rId17"/>
+    <p:sldId id="266" r:id="rId18"/>
+    <p:sldId id="267" r:id="rId19"/>
+    <p:sldId id="268" r:id="rId20"/>
   </p:sldIdLst>
   <p:sldSz cx="12191695" cy="6858000" type="screen4x3"/>
   <p:notesSz cx="6858000" cy="9144000"/>
@@ -582,6 +585,216 @@
           <a:p>
             <a:r>
               <a:t>Takt = 157.5 h / 120 applications = 1.31 h. PCE = VA / lead time. Step times mocked - validate in POC week 1 via time-and-motion + LOS timestamps.</a:t>
+            </a:r>
+          </a:p>
+        </p:txBody>
+      </p:sp>
+      <p:sp>
+        <p:nvSpPr>
+          <p:cNvPr id="4" name="Slide Number Placeholder 3"/>
+          <p:cNvSpPr>
+            <a:spLocks noGrp="1"/>
+          </p:cNvSpPr>
+          <p:nvPr>
+            <p:ph type="sldNum" idx="5" sz="quarter"/>
+          </p:nvPr>
+        </p:nvSpPr>
+        <p:spPr/>
+      </p:sp>
+    </p:spTree>
+  </p:cSld>
+  <p:clrMapOvr>
+    <a:masterClrMapping/>
+  </p:clrMapOvr>
+</p:notes>
+</file>
+
+<file path=ppt/notesSlides/notesSlide3.xml><?xml version="1.0" encoding="utf-8"?>
+<p:notes xmlns:a="http://schemas.openxmlformats.org/drawingml/2006/main" xmlns:p="http://schemas.openxmlformats.org/presentationml/2006/main" xmlns:r="http://schemas.openxmlformats.org/officeDocument/2006/relationships">
+  <p:cSld>
+    <p:spTree>
+      <p:nvGrpSpPr>
+        <p:cNvPr id="1" name=""/>
+        <p:cNvGrpSpPr/>
+        <p:nvPr/>
+      </p:nvGrpSpPr>
+      <p:grpSpPr>
+        <a:xfrm>
+          <a:off x="0" y="0"/>
+          <a:ext cx="0" cy="0"/>
+          <a:chOff x="0" y="0"/>
+          <a:chExt cx="0" cy="0"/>
+        </a:xfrm>
+      </p:grpSpPr>
+      <p:sp>
+        <p:nvSpPr>
+          <p:cNvPr id="2" name="Slide Image Placeholder 1"/>
+          <p:cNvSpPr>
+            <a:spLocks noGrp="1"/>
+          </p:cNvSpPr>
+          <p:nvPr>
+            <p:ph type="sldImg" idx="2"/>
+          </p:nvPr>
+        </p:nvSpPr>
+        <p:spPr/>
+      </p:sp>
+      <p:sp>
+        <p:nvSpPr>
+          <p:cNvPr id="3" name="Notes Placeholder 2"/>
+          <p:cNvSpPr>
+            <a:spLocks noGrp="1"/>
+          </p:cNvSpPr>
+          <p:nvPr>
+            <p:ph type="body" idx="3" sz="quarter"/>
+          </p:nvPr>
+        </p:nvSpPr>
+        <p:spPr/>
+        <p:txBody>
+          <a:bodyPr/>
+          <a:lstStyle/>
+          <a:p>
+            <a:r>
+              <a:t>What actually runs today. Same agents and code path as production; only the platform services change.</a:t>
+            </a:r>
+          </a:p>
+        </p:txBody>
+      </p:sp>
+      <p:sp>
+        <p:nvSpPr>
+          <p:cNvPr id="4" name="Slide Number Placeholder 3"/>
+          <p:cNvSpPr>
+            <a:spLocks noGrp="1"/>
+          </p:cNvSpPr>
+          <p:nvPr>
+            <p:ph type="sldNum" idx="5" sz="quarter"/>
+          </p:nvPr>
+        </p:nvSpPr>
+        <p:spPr/>
+      </p:sp>
+    </p:spTree>
+  </p:cSld>
+  <p:clrMapOvr>
+    <a:masterClrMapping/>
+  </p:clrMapOvr>
+</p:notes>
+</file>
+
+<file path=ppt/notesSlides/notesSlide4.xml><?xml version="1.0" encoding="utf-8"?>
+<p:notes xmlns:a="http://schemas.openxmlformats.org/drawingml/2006/main" xmlns:p="http://schemas.openxmlformats.org/presentationml/2006/main" xmlns:r="http://schemas.openxmlformats.org/officeDocument/2006/relationships">
+  <p:cSld>
+    <p:spTree>
+      <p:nvGrpSpPr>
+        <p:cNvPr id="1" name=""/>
+        <p:cNvGrpSpPr/>
+        <p:nvPr/>
+      </p:nvGrpSpPr>
+      <p:grpSpPr>
+        <a:xfrm>
+          <a:off x="0" y="0"/>
+          <a:ext cx="0" cy="0"/>
+          <a:chOff x="0" y="0"/>
+          <a:chExt cx="0" cy="0"/>
+        </a:xfrm>
+      </p:grpSpPr>
+      <p:sp>
+        <p:nvSpPr>
+          <p:cNvPr id="2" name="Slide Image Placeholder 1"/>
+          <p:cNvSpPr>
+            <a:spLocks noGrp="1"/>
+          </p:cNvSpPr>
+          <p:nvPr>
+            <p:ph type="sldImg" idx="2"/>
+          </p:nvPr>
+        </p:nvSpPr>
+        <p:spPr/>
+      </p:sp>
+      <p:sp>
+        <p:nvSpPr>
+          <p:cNvPr id="3" name="Notes Placeholder 2"/>
+          <p:cNvSpPr>
+            <a:spLocks noGrp="1"/>
+          </p:cNvSpPr>
+          <p:nvPr>
+            <p:ph type="body" idx="3" sz="quarter"/>
+          </p:nvPr>
+        </p:nvSpPr>
+        <p:spPr/>
+        <p:txBody>
+          <a:bodyPr/>
+          <a:lstStyle/>
+          <a:p>
+            <a:r>
+              <a:t>Target AWS deployment. Client-cloud agnostic: the same container images, agent graph and MCP tool contracts deploy to either cloud; only managed services differ.</a:t>
+            </a:r>
+          </a:p>
+        </p:txBody>
+      </p:sp>
+      <p:sp>
+        <p:nvSpPr>
+          <p:cNvPr id="4" name="Slide Number Placeholder 3"/>
+          <p:cNvSpPr>
+            <a:spLocks noGrp="1"/>
+          </p:cNvSpPr>
+          <p:nvPr>
+            <p:ph type="sldNum" idx="5" sz="quarter"/>
+          </p:nvPr>
+        </p:nvSpPr>
+        <p:spPr/>
+      </p:sp>
+    </p:spTree>
+  </p:cSld>
+  <p:clrMapOvr>
+    <a:masterClrMapping/>
+  </p:clrMapOvr>
+</p:notes>
+</file>
+
+<file path=ppt/notesSlides/notesSlide5.xml><?xml version="1.0" encoding="utf-8"?>
+<p:notes xmlns:a="http://schemas.openxmlformats.org/drawingml/2006/main" xmlns:p="http://schemas.openxmlformats.org/presentationml/2006/main" xmlns:r="http://schemas.openxmlformats.org/officeDocument/2006/relationships">
+  <p:cSld>
+    <p:spTree>
+      <p:nvGrpSpPr>
+        <p:cNvPr id="1" name=""/>
+        <p:cNvGrpSpPr/>
+        <p:nvPr/>
+      </p:nvGrpSpPr>
+      <p:grpSpPr>
+        <a:xfrm>
+          <a:off x="0" y="0"/>
+          <a:ext cx="0" cy="0"/>
+          <a:chOff x="0" y="0"/>
+          <a:chExt cx="0" cy="0"/>
+        </a:xfrm>
+      </p:grpSpPr>
+      <p:sp>
+        <p:nvSpPr>
+          <p:cNvPr id="2" name="Slide Image Placeholder 1"/>
+          <p:cNvSpPr>
+            <a:spLocks noGrp="1"/>
+          </p:cNvSpPr>
+          <p:nvPr>
+            <p:ph type="sldImg" idx="2"/>
+          </p:nvPr>
+        </p:nvSpPr>
+        <p:spPr/>
+      </p:sp>
+      <p:sp>
+        <p:nvSpPr>
+          <p:cNvPr id="3" name="Notes Placeholder 2"/>
+          <p:cNvSpPr>
+            <a:spLocks noGrp="1"/>
+          </p:cNvSpPr>
+          <p:nvPr>
+            <p:ph type="body" idx="3" sz="quarter"/>
+          </p:nvPr>
+        </p:nvSpPr>
+        <p:spPr/>
+        <p:txBody>
+          <a:bodyPr/>
+          <a:lstStyle/>
+          <a:p>
+            <a:r>
+              <a:t>Target Azure deployment. Client-cloud agnostic: the same container images, agent graph and MCP tool contracts deploy to either cloud; only managed services differ.</a:t>
             </a:r>
           </a:p>
         </p:txBody>
@@ -4887,6 +5100,576 @@
           </a:p>
         </p:txBody>
       </p:sp>
+    </p:spTree>
+  </p:cSld>
+  <p:clrMapOvr>
+    <a:masterClrMapping/>
+  </p:clrMapOvr>
+</p:sld>
+</file>
+
+<file path=ppt/slides/slide11.xml><?xml version="1.0" encoding="utf-8"?>
+<p:sld xmlns:a="http://schemas.openxmlformats.org/drawingml/2006/main" xmlns:p="http://schemas.openxmlformats.org/presentationml/2006/main" xmlns:r="http://schemas.openxmlformats.org/officeDocument/2006/relationships">
+  <p:cSld>
+    <p:spTree>
+      <p:nvGrpSpPr>
+        <p:cNvPr id="1" name=""/>
+        <p:cNvGrpSpPr/>
+        <p:nvPr/>
+      </p:nvGrpSpPr>
+      <p:grpSpPr/>
+      <p:sp>
+        <p:nvSpPr>
+          <p:cNvPr id="2" name="Rectangle 1"/>
+          <p:cNvSpPr/>
+          <p:nvPr/>
+        </p:nvSpPr>
+        <p:spPr>
+          <a:xfrm>
+            <a:off x="0" y="0"/>
+            <a:ext cx="12191695" cy="109728"/>
+          </a:xfrm>
+          <a:prstGeom prst="rect">
+            <a:avLst/>
+          </a:prstGeom>
+          <a:solidFill>
+            <a:srgbClr val="2A9D8F"/>
+          </a:solidFill>
+          <a:ln>
+            <a:noFill/>
+          </a:ln>
+        </p:spPr>
+        <p:style>
+          <a:lnRef idx="1">
+            <a:schemeClr val="accent1"/>
+          </a:lnRef>
+          <a:fillRef idx="3">
+            <a:schemeClr val="accent1"/>
+          </a:fillRef>
+          <a:effectRef idx="2">
+            <a:schemeClr val="accent1"/>
+          </a:effectRef>
+          <a:fontRef idx="minor">
+            <a:schemeClr val="lt1"/>
+          </a:fontRef>
+        </p:style>
+        <p:txBody>
+          <a:bodyPr rtlCol="0" anchor="ctr"/>
+          <a:lstStyle/>
+          <a:p>
+            <a:pPr algn="ctr"/>
+          </a:p>
+        </p:txBody>
+      </p:sp>
+      <p:sp>
+        <p:nvSpPr>
+          <p:cNvPr id="3" name="TextBox 2"/>
+          <p:cNvSpPr txBox="1"/>
+          <p:nvPr/>
+        </p:nvSpPr>
+        <p:spPr>
+          <a:xfrm>
+            <a:off x="457200" y="228600"/>
+            <a:ext cx="10972800" cy="274320"/>
+          </a:xfrm>
+          <a:prstGeom prst="rect">
+            <a:avLst/>
+          </a:prstGeom>
+          <a:noFill/>
+        </p:spPr>
+        <p:txBody>
+          <a:bodyPr wrap="square">
+            <a:spAutoFit/>
+          </a:bodyPr>
+          <a:lstStyle/>
+          <a:p>
+            <a:pPr algn="l">
+              <a:defRPr sz="1100" b="1">
+                <a:solidFill>
+                  <a:srgbClr val="2A9D8F"/>
+                </a:solidFill>
+              </a:defRPr>
+            </a:pPr>
+            <a:r>
+              <a:t>APPENDIX · DEPLOYMENT</a:t>
+            </a:r>
+          </a:p>
+        </p:txBody>
+      </p:sp>
+      <p:sp>
+        <p:nvSpPr>
+          <p:cNvPr id="4" name="TextBox 3"/>
+          <p:cNvSpPr txBox="1"/>
+          <p:nvPr/>
+        </p:nvSpPr>
+        <p:spPr>
+          <a:xfrm>
+            <a:off x="457200" y="457200"/>
+            <a:ext cx="11247120" cy="731520"/>
+          </a:xfrm>
+          <a:prstGeom prst="rect">
+            <a:avLst/>
+          </a:prstGeom>
+          <a:noFill/>
+        </p:spPr>
+        <p:txBody>
+          <a:bodyPr wrap="square">
+            <a:spAutoFit/>
+          </a:bodyPr>
+          <a:lstStyle/>
+          <a:p>
+            <a:pPr algn="l">
+              <a:defRPr sz="2600" b="1">
+                <a:solidFill>
+                  <a:srgbClr val="1F3A5F"/>
+                </a:solidFill>
+              </a:defRPr>
+            </a:pPr>
+            <a:r>
+              <a:t>Appendix A · POC deployment today: Docker Compose with a local GPU LLM</a:t>
+            </a:r>
+          </a:p>
+        </p:txBody>
+      </p:sp>
+      <p:sp>
+        <p:nvSpPr>
+          <p:cNvPr id="5" name="TextBox 4"/>
+          <p:cNvSpPr txBox="1"/>
+          <p:nvPr/>
+        </p:nvSpPr>
+        <p:spPr>
+          <a:xfrm>
+            <a:off x="457200" y="6446520"/>
+            <a:ext cx="11247120" cy="274320"/>
+          </a:xfrm>
+          <a:prstGeom prst="rect">
+            <a:avLst/>
+          </a:prstGeom>
+          <a:noFill/>
+        </p:spPr>
+        <p:txBody>
+          <a:bodyPr wrap="square">
+            <a:spAutoFit/>
+          </a:bodyPr>
+          <a:lstStyle/>
+          <a:p>
+            <a:pPr algn="l">
+              <a:defRPr sz="900" b="0">
+                <a:solidFill>
+                  <a:srgbClr val="6C757D"/>
+                </a:solidFill>
+              </a:defRPr>
+            </a:pPr>
+            <a:r>
+              <a:t>Agentic Loan Lifecycle Management · FDE client challenge · synthetic data, mocked step times   |   11</a:t>
+            </a:r>
+          </a:p>
+        </p:txBody>
+      </p:sp>
+      <p:pic>
+        <p:nvPicPr>
+          <p:cNvPr id="6" name="Picture 5" descr="poc_deployment.png"/>
+          <p:cNvPicPr>
+            <a:picLocks noChangeAspect="1"/>
+          </p:cNvPicPr>
+          <p:nvPr/>
+        </p:nvPicPr>
+        <p:blipFill>
+          <a:blip r:embed="rId2"/>
+          <a:stretch>
+            <a:fillRect/>
+          </a:stretch>
+        </p:blipFill>
+        <p:spPr>
+          <a:xfrm>
+            <a:off x="274320" y="1249612"/>
+            <a:ext cx="11612879" cy="5044575"/>
+          </a:xfrm>
+          <a:prstGeom prst="rect">
+            <a:avLst/>
+          </a:prstGeom>
+        </p:spPr>
+      </p:pic>
+    </p:spTree>
+  </p:cSld>
+  <p:clrMapOvr>
+    <a:masterClrMapping/>
+  </p:clrMapOvr>
+</p:sld>
+</file>
+
+<file path=ppt/slides/slide12.xml><?xml version="1.0" encoding="utf-8"?>
+<p:sld xmlns:a="http://schemas.openxmlformats.org/drawingml/2006/main" xmlns:p="http://schemas.openxmlformats.org/presentationml/2006/main" xmlns:r="http://schemas.openxmlformats.org/officeDocument/2006/relationships">
+  <p:cSld>
+    <p:spTree>
+      <p:nvGrpSpPr>
+        <p:cNvPr id="1" name=""/>
+        <p:cNvGrpSpPr/>
+        <p:nvPr/>
+      </p:nvGrpSpPr>
+      <p:grpSpPr/>
+      <p:sp>
+        <p:nvSpPr>
+          <p:cNvPr id="2" name="Rectangle 1"/>
+          <p:cNvSpPr/>
+          <p:nvPr/>
+        </p:nvSpPr>
+        <p:spPr>
+          <a:xfrm>
+            <a:off x="0" y="0"/>
+            <a:ext cx="12191695" cy="109728"/>
+          </a:xfrm>
+          <a:prstGeom prst="rect">
+            <a:avLst/>
+          </a:prstGeom>
+          <a:solidFill>
+            <a:srgbClr val="2A9D8F"/>
+          </a:solidFill>
+          <a:ln>
+            <a:noFill/>
+          </a:ln>
+        </p:spPr>
+        <p:style>
+          <a:lnRef idx="1">
+            <a:schemeClr val="accent1"/>
+          </a:lnRef>
+          <a:fillRef idx="3">
+            <a:schemeClr val="accent1"/>
+          </a:fillRef>
+          <a:effectRef idx="2">
+            <a:schemeClr val="accent1"/>
+          </a:effectRef>
+          <a:fontRef idx="minor">
+            <a:schemeClr val="lt1"/>
+          </a:fontRef>
+        </p:style>
+        <p:txBody>
+          <a:bodyPr rtlCol="0" anchor="ctr"/>
+          <a:lstStyle/>
+          <a:p>
+            <a:pPr algn="ctr"/>
+          </a:p>
+        </p:txBody>
+      </p:sp>
+      <p:sp>
+        <p:nvSpPr>
+          <p:cNvPr id="3" name="TextBox 2"/>
+          <p:cNvSpPr txBox="1"/>
+          <p:nvPr/>
+        </p:nvSpPr>
+        <p:spPr>
+          <a:xfrm>
+            <a:off x="457200" y="228600"/>
+            <a:ext cx="10972800" cy="274320"/>
+          </a:xfrm>
+          <a:prstGeom prst="rect">
+            <a:avLst/>
+          </a:prstGeom>
+          <a:noFill/>
+        </p:spPr>
+        <p:txBody>
+          <a:bodyPr wrap="square">
+            <a:spAutoFit/>
+          </a:bodyPr>
+          <a:lstStyle/>
+          <a:p>
+            <a:pPr algn="l">
+              <a:defRPr sz="1100" b="1">
+                <a:solidFill>
+                  <a:srgbClr val="2A9D8F"/>
+                </a:solidFill>
+              </a:defRPr>
+            </a:pPr>
+            <a:r>
+              <a:t>APPENDIX · DEPLOYMENT</a:t>
+            </a:r>
+          </a:p>
+        </p:txBody>
+      </p:sp>
+      <p:sp>
+        <p:nvSpPr>
+          <p:cNvPr id="4" name="TextBox 3"/>
+          <p:cNvSpPr txBox="1"/>
+          <p:nvPr/>
+        </p:nvSpPr>
+        <p:spPr>
+          <a:xfrm>
+            <a:off x="457200" y="457200"/>
+            <a:ext cx="11247120" cy="731520"/>
+          </a:xfrm>
+          <a:prstGeom prst="rect">
+            <a:avLst/>
+          </a:prstGeom>
+          <a:noFill/>
+        </p:spPr>
+        <p:txBody>
+          <a:bodyPr wrap="square">
+            <a:spAutoFit/>
+          </a:bodyPr>
+          <a:lstStyle/>
+          <a:p>
+            <a:pPr algn="l">
+              <a:defRPr sz="2600" b="1">
+                <a:solidFill>
+                  <a:srgbClr val="1F3A5F"/>
+                </a:solidFill>
+              </a:defRPr>
+            </a:pPr>
+            <a:r>
+              <a:t>Appendix B · AWS production deployment: agents, MCP server, PostgreSQL</a:t>
+            </a:r>
+          </a:p>
+        </p:txBody>
+      </p:sp>
+      <p:sp>
+        <p:nvSpPr>
+          <p:cNvPr id="5" name="TextBox 4"/>
+          <p:cNvSpPr txBox="1"/>
+          <p:nvPr/>
+        </p:nvSpPr>
+        <p:spPr>
+          <a:xfrm>
+            <a:off x="457200" y="6446520"/>
+            <a:ext cx="11247120" cy="274320"/>
+          </a:xfrm>
+          <a:prstGeom prst="rect">
+            <a:avLst/>
+          </a:prstGeom>
+          <a:noFill/>
+        </p:spPr>
+        <p:txBody>
+          <a:bodyPr wrap="square">
+            <a:spAutoFit/>
+          </a:bodyPr>
+          <a:lstStyle/>
+          <a:p>
+            <a:pPr algn="l">
+              <a:defRPr sz="900" b="0">
+                <a:solidFill>
+                  <a:srgbClr val="6C757D"/>
+                </a:solidFill>
+              </a:defRPr>
+            </a:pPr>
+            <a:r>
+              <a:t>Agentic Loan Lifecycle Management · FDE client challenge · synthetic data, mocked step times   |   12</a:t>
+            </a:r>
+          </a:p>
+        </p:txBody>
+      </p:sp>
+      <p:pic>
+        <p:nvPicPr>
+          <p:cNvPr id="6" name="Picture 5" descr="a1_deploy_aws.png"/>
+          <p:cNvPicPr>
+            <a:picLocks noChangeAspect="1"/>
+          </p:cNvPicPr>
+          <p:nvPr/>
+        </p:nvPicPr>
+        <p:blipFill>
+          <a:blip r:embed="rId2"/>
+          <a:stretch>
+            <a:fillRect/>
+          </a:stretch>
+        </p:blipFill>
+        <p:spPr>
+          <a:xfrm>
+            <a:off x="595564" y="1097280"/>
+            <a:ext cx="10970390" cy="5303520"/>
+          </a:xfrm>
+          <a:prstGeom prst="rect">
+            <a:avLst/>
+          </a:prstGeom>
+        </p:spPr>
+      </p:pic>
+    </p:spTree>
+  </p:cSld>
+  <p:clrMapOvr>
+    <a:masterClrMapping/>
+  </p:clrMapOvr>
+</p:sld>
+</file>
+
+<file path=ppt/slides/slide13.xml><?xml version="1.0" encoding="utf-8"?>
+<p:sld xmlns:a="http://schemas.openxmlformats.org/drawingml/2006/main" xmlns:p="http://schemas.openxmlformats.org/presentationml/2006/main" xmlns:r="http://schemas.openxmlformats.org/officeDocument/2006/relationships">
+  <p:cSld>
+    <p:spTree>
+      <p:nvGrpSpPr>
+        <p:cNvPr id="1" name=""/>
+        <p:cNvGrpSpPr/>
+        <p:nvPr/>
+      </p:nvGrpSpPr>
+      <p:grpSpPr/>
+      <p:sp>
+        <p:nvSpPr>
+          <p:cNvPr id="2" name="Rectangle 1"/>
+          <p:cNvSpPr/>
+          <p:nvPr/>
+        </p:nvSpPr>
+        <p:spPr>
+          <a:xfrm>
+            <a:off x="0" y="0"/>
+            <a:ext cx="12191695" cy="109728"/>
+          </a:xfrm>
+          <a:prstGeom prst="rect">
+            <a:avLst/>
+          </a:prstGeom>
+          <a:solidFill>
+            <a:srgbClr val="2A9D8F"/>
+          </a:solidFill>
+          <a:ln>
+            <a:noFill/>
+          </a:ln>
+        </p:spPr>
+        <p:style>
+          <a:lnRef idx="1">
+            <a:schemeClr val="accent1"/>
+          </a:lnRef>
+          <a:fillRef idx="3">
+            <a:schemeClr val="accent1"/>
+          </a:fillRef>
+          <a:effectRef idx="2">
+            <a:schemeClr val="accent1"/>
+          </a:effectRef>
+          <a:fontRef idx="minor">
+            <a:schemeClr val="lt1"/>
+          </a:fontRef>
+        </p:style>
+        <p:txBody>
+          <a:bodyPr rtlCol="0" anchor="ctr"/>
+          <a:lstStyle/>
+          <a:p>
+            <a:pPr algn="ctr"/>
+          </a:p>
+        </p:txBody>
+      </p:sp>
+      <p:sp>
+        <p:nvSpPr>
+          <p:cNvPr id="3" name="TextBox 2"/>
+          <p:cNvSpPr txBox="1"/>
+          <p:nvPr/>
+        </p:nvSpPr>
+        <p:spPr>
+          <a:xfrm>
+            <a:off x="457200" y="228600"/>
+            <a:ext cx="10972800" cy="274320"/>
+          </a:xfrm>
+          <a:prstGeom prst="rect">
+            <a:avLst/>
+          </a:prstGeom>
+          <a:noFill/>
+        </p:spPr>
+        <p:txBody>
+          <a:bodyPr wrap="square">
+            <a:spAutoFit/>
+          </a:bodyPr>
+          <a:lstStyle/>
+          <a:p>
+            <a:pPr algn="l">
+              <a:defRPr sz="1100" b="1">
+                <a:solidFill>
+                  <a:srgbClr val="2A9D8F"/>
+                </a:solidFill>
+              </a:defRPr>
+            </a:pPr>
+            <a:r>
+              <a:t>APPENDIX · DEPLOYMENT</a:t>
+            </a:r>
+          </a:p>
+        </p:txBody>
+      </p:sp>
+      <p:sp>
+        <p:nvSpPr>
+          <p:cNvPr id="4" name="TextBox 3"/>
+          <p:cNvSpPr txBox="1"/>
+          <p:nvPr/>
+        </p:nvSpPr>
+        <p:spPr>
+          <a:xfrm>
+            <a:off x="457200" y="457200"/>
+            <a:ext cx="11247120" cy="731520"/>
+          </a:xfrm>
+          <a:prstGeom prst="rect">
+            <a:avLst/>
+          </a:prstGeom>
+          <a:noFill/>
+        </p:spPr>
+        <p:txBody>
+          <a:bodyPr wrap="square">
+            <a:spAutoFit/>
+          </a:bodyPr>
+          <a:lstStyle/>
+          <a:p>
+            <a:pPr algn="l">
+              <a:defRPr sz="2600" b="1">
+                <a:solidFill>
+                  <a:srgbClr val="1F3A5F"/>
+                </a:solidFill>
+              </a:defRPr>
+            </a:pPr>
+            <a:r>
+              <a:t>Appendix C · Azure production deployment: agents, MCP server, PostgreSQL</a:t>
+            </a:r>
+          </a:p>
+        </p:txBody>
+      </p:sp>
+      <p:sp>
+        <p:nvSpPr>
+          <p:cNvPr id="5" name="TextBox 4"/>
+          <p:cNvSpPr txBox="1"/>
+          <p:nvPr/>
+        </p:nvSpPr>
+        <p:spPr>
+          <a:xfrm>
+            <a:off x="457200" y="6446520"/>
+            <a:ext cx="11247120" cy="274320"/>
+          </a:xfrm>
+          <a:prstGeom prst="rect">
+            <a:avLst/>
+          </a:prstGeom>
+          <a:noFill/>
+        </p:spPr>
+        <p:txBody>
+          <a:bodyPr wrap="square">
+            <a:spAutoFit/>
+          </a:bodyPr>
+          <a:lstStyle/>
+          <a:p>
+            <a:pPr algn="l">
+              <a:defRPr sz="900" b="0">
+                <a:solidFill>
+                  <a:srgbClr val="6C757D"/>
+                </a:solidFill>
+              </a:defRPr>
+            </a:pPr>
+            <a:r>
+              <a:t>Agentic Loan Lifecycle Management · FDE client challenge · synthetic data, mocked step times   |   13</a:t>
+            </a:r>
+          </a:p>
+        </p:txBody>
+      </p:sp>
+      <p:pic>
+        <p:nvPicPr>
+          <p:cNvPr id="6" name="Picture 5" descr="a1_deploy_azure.png"/>
+          <p:cNvPicPr>
+            <a:picLocks noChangeAspect="1"/>
+          </p:cNvPicPr>
+          <p:nvPr/>
+        </p:nvPicPr>
+        <p:blipFill>
+          <a:blip r:embed="rId2"/>
+          <a:stretch>
+            <a:fillRect/>
+          </a:stretch>
+        </p:blipFill>
+        <p:spPr>
+          <a:xfrm>
+            <a:off x="595564" y="1097280"/>
+            <a:ext cx="10970390" cy="5303520"/>
+          </a:xfrm>
+          <a:prstGeom prst="rect">
+            <a:avLst/>
+          </a:prstGeom>
+        </p:spPr>
+      </p:pic>
     </p:spTree>
   </p:cSld>
   <p:clrMapOvr>

</xml_diff>